<commit_message>
no puedo sincronizar este reporte
</commit_message>
<xml_diff>
--- a/Reporte 220926.pptx
+++ b/Reporte 220926.pptx
@@ -5,7 +5,7 @@
     <p:sldMasterId id="2147483672" r:id="rId1"/>
   </p:sldMasterIdLst>
   <p:notesMasterIdLst>
-    <p:notesMasterId r:id="rId20"/>
+    <p:notesMasterId r:id="rId19"/>
   </p:notesMasterIdLst>
   <p:sldIdLst>
     <p:sldId id="350" r:id="rId2"/>
@@ -24,23 +24,22 @@
     <p:sldId id="412" r:id="rId15"/>
     <p:sldId id="371" r:id="rId16"/>
     <p:sldId id="413" r:id="rId17"/>
-    <p:sldId id="414" r:id="rId18"/>
-    <p:sldId id="280" r:id="rId19"/>
+    <p:sldId id="280" r:id="rId18"/>
   </p:sldIdLst>
   <p:sldSz cx="9144000" cy="5143500" type="screen16x9"/>
   <p:notesSz cx="6858000" cy="9144000"/>
   <p:embeddedFontLst>
     <p:embeddedFont>
       <p:font typeface="Montserrat" panose="00000500000000000000" pitchFamily="2" charset="0"/>
-      <p:regular r:id="rId21"/>
-      <p:bold r:id="rId22"/>
-      <p:italic r:id="rId23"/>
-      <p:boldItalic r:id="rId24"/>
+      <p:regular r:id="rId20"/>
+      <p:bold r:id="rId21"/>
+      <p:italic r:id="rId22"/>
+      <p:boldItalic r:id="rId23"/>
     </p:embeddedFont>
     <p:embeddedFont>
       <p:font typeface="Montserrat Black" panose="00000A00000000000000" pitchFamily="2" charset="0"/>
-      <p:bold r:id="rId25"/>
-      <p:boldItalic r:id="rId26"/>
+      <p:bold r:id="rId24"/>
+      <p:boldItalic r:id="rId25"/>
     </p:embeddedFont>
   </p:embeddedFontLst>
   <p:defaultTextStyle>
@@ -6513,7 +6512,7 @@
                   <a:srgbClr val="D8AB72"/>
                 </a:solidFill>
               </a:rPr>
-              <a:t>22</a:t>
+              <a:t>23</a:t>
             </a:r>
             <a:r>
               <a:rPr kumimoji="0" lang="es-MX" sz="1600" b="0" i="0" u="none" strike="noStrike" kern="0" cap="none" spc="0" normalizeH="0" baseline="0" noProof="0" dirty="0">
@@ -6778,10 +6777,10 @@
       </p:sp>
       <p:pic>
         <p:nvPicPr>
-          <p:cNvPr id="4" name="Imagen 3">
+          <p:cNvPr id="5" name="Imagen 4">
             <a:extLst>
               <a:ext uri="{FF2B5EF4-FFF2-40B4-BE49-F238E27FC236}">
-                <a16:creationId xmlns:a16="http://schemas.microsoft.com/office/drawing/2014/main" id="{B8EAB0EB-3EA5-C970-109F-87B9E454A3C9}"/>
+                <a16:creationId xmlns:a16="http://schemas.microsoft.com/office/drawing/2014/main" id="{DB8147C3-7D7A-A15F-1A69-DF919B33D683}"/>
               </a:ext>
             </a:extLst>
           </p:cNvPr>
@@ -6798,8 +6797,8 @@
         </p:blipFill>
         <p:spPr>
           <a:xfrm>
-            <a:off x="0" y="747543"/>
-            <a:ext cx="9144000" cy="3791290"/>
+            <a:off x="-6725" y="718404"/>
+            <a:ext cx="9144000" cy="3849568"/>
           </a:xfrm>
           <a:prstGeom prst="rect">
             <a:avLst/>
@@ -6884,10 +6883,10 @@
       </p:sp>
       <p:pic>
         <p:nvPicPr>
-          <p:cNvPr id="4" name="Imagen 3">
+          <p:cNvPr id="3" name="Imagen 2">
             <a:extLst>
               <a:ext uri="{FF2B5EF4-FFF2-40B4-BE49-F238E27FC236}">
-                <a16:creationId xmlns:a16="http://schemas.microsoft.com/office/drawing/2014/main" id="{D1A68F3D-0FF6-1B92-D418-71F7C64E0C5F}"/>
+                <a16:creationId xmlns:a16="http://schemas.microsoft.com/office/drawing/2014/main" id="{539B2228-BD7F-B965-DBB4-7658DBB64991}"/>
               </a:ext>
             </a:extLst>
           </p:cNvPr>
@@ -6904,8 +6903,8 @@
         </p:blipFill>
         <p:spPr>
           <a:xfrm>
-            <a:off x="0" y="1187768"/>
-            <a:ext cx="9144000" cy="2910840"/>
+            <a:off x="0" y="1260722"/>
+            <a:ext cx="9144000" cy="2924455"/>
           </a:xfrm>
           <a:prstGeom prst="rect">
             <a:avLst/>
@@ -6990,10 +6989,10 @@
       </p:sp>
       <p:pic>
         <p:nvPicPr>
-          <p:cNvPr id="4" name="Imagen 3">
+          <p:cNvPr id="5" name="Imagen 4">
             <a:extLst>
               <a:ext uri="{FF2B5EF4-FFF2-40B4-BE49-F238E27FC236}">
-                <a16:creationId xmlns:a16="http://schemas.microsoft.com/office/drawing/2014/main" id="{2B8F88D1-049B-50EE-251A-F0FFA8A8C54B}"/>
+                <a16:creationId xmlns:a16="http://schemas.microsoft.com/office/drawing/2014/main" id="{D6A740B0-C018-238C-B19F-5A018384C34F}"/>
               </a:ext>
             </a:extLst>
           </p:cNvPr>
@@ -7010,8 +7009,8 @@
         </p:blipFill>
         <p:spPr>
           <a:xfrm>
-            <a:off x="0" y="595067"/>
-            <a:ext cx="9144000" cy="4096242"/>
+            <a:off x="0" y="589150"/>
+            <a:ext cx="9144000" cy="4108076"/>
           </a:xfrm>
           <a:prstGeom prst="rect">
             <a:avLst/>
@@ -7096,10 +7095,10 @@
       </p:sp>
       <p:pic>
         <p:nvPicPr>
-          <p:cNvPr id="4" name="Imagen 3">
+          <p:cNvPr id="3" name="Imagen 2">
             <a:extLst>
               <a:ext uri="{FF2B5EF4-FFF2-40B4-BE49-F238E27FC236}">
-                <a16:creationId xmlns:a16="http://schemas.microsoft.com/office/drawing/2014/main" id="{EBFC991C-BB11-1556-7937-5795E71FE591}"/>
+                <a16:creationId xmlns:a16="http://schemas.microsoft.com/office/drawing/2014/main" id="{93E65B8D-5A6A-062B-48A3-6312D0BCCCF9}"/>
               </a:ext>
             </a:extLst>
           </p:cNvPr>
@@ -7116,8 +7115,8 @@
         </p:blipFill>
         <p:spPr>
           <a:xfrm>
-            <a:off x="0" y="1146432"/>
-            <a:ext cx="9144000" cy="2993511"/>
+            <a:off x="0" y="1066397"/>
+            <a:ext cx="9144000" cy="3010705"/>
           </a:xfrm>
           <a:prstGeom prst="rect">
             <a:avLst/>
@@ -7202,10 +7201,10 @@
       </p:sp>
       <p:pic>
         <p:nvPicPr>
-          <p:cNvPr id="4" name="Imagen 3">
+          <p:cNvPr id="3" name="Imagen 2">
             <a:extLst>
               <a:ext uri="{FF2B5EF4-FFF2-40B4-BE49-F238E27FC236}">
-                <a16:creationId xmlns:a16="http://schemas.microsoft.com/office/drawing/2014/main" id="{121C6D09-EE3A-1777-40A1-2349F8FA2360}"/>
+                <a16:creationId xmlns:a16="http://schemas.microsoft.com/office/drawing/2014/main" id="{CAE11144-0BC0-FCBA-64EF-A6DF2467D9F5}"/>
               </a:ext>
             </a:extLst>
           </p:cNvPr>
@@ -7222,8 +7221,8 @@
         </p:blipFill>
         <p:spPr>
           <a:xfrm>
-            <a:off x="0" y="459014"/>
-            <a:ext cx="9144000" cy="4368348"/>
+            <a:off x="0" y="1559210"/>
+            <a:ext cx="9144000" cy="2167956"/>
           </a:xfrm>
           <a:prstGeom prst="rect">
             <a:avLst/>
@@ -7314,10 +7313,10 @@
       </p:sp>
       <p:pic>
         <p:nvPicPr>
-          <p:cNvPr id="4" name="Imagen 3">
+          <p:cNvPr id="3" name="Imagen 2">
             <a:extLst>
               <a:ext uri="{FF2B5EF4-FFF2-40B4-BE49-F238E27FC236}">
-                <a16:creationId xmlns:a16="http://schemas.microsoft.com/office/drawing/2014/main" id="{94CE5F28-CB36-5B16-2569-99860955875F}"/>
+                <a16:creationId xmlns:a16="http://schemas.microsoft.com/office/drawing/2014/main" id="{37B8D067-3579-9A68-D51A-9D027EFEDF62}"/>
               </a:ext>
             </a:extLst>
           </p:cNvPr>
@@ -7334,8 +7333,8 @@
         </p:blipFill>
         <p:spPr>
           <a:xfrm>
-            <a:off x="588353" y="445960"/>
-            <a:ext cx="7894269" cy="4609405"/>
+            <a:off x="0" y="511851"/>
+            <a:ext cx="9144000" cy="4262673"/>
           </a:xfrm>
           <a:prstGeom prst="rect">
             <a:avLst/>
@@ -7356,118 +7355,6 @@
 </file>
 
 <file path=ppt/slides/slide17.xml><?xml version="1.0" encoding="utf-8"?>
-<p:sld xmlns:a="http://schemas.openxmlformats.org/drawingml/2006/main" xmlns:r="http://schemas.openxmlformats.org/officeDocument/2006/relationships" xmlns:p="http://schemas.openxmlformats.org/presentationml/2006/main">
-  <p:cSld>
-    <p:bg>
-      <p:bgPr>
-        <a:solidFill>
-          <a:srgbClr val="F8F9FA"/>
-        </a:solidFill>
-        <a:effectLst/>
-      </p:bgPr>
-    </p:bg>
-    <p:spTree>
-      <p:nvGrpSpPr>
-        <p:cNvPr id="1" name="">
-          <a:extLst>
-            <a:ext uri="{FF2B5EF4-FFF2-40B4-BE49-F238E27FC236}">
-              <a16:creationId xmlns:a16="http://schemas.microsoft.com/office/drawing/2014/main" id="{FB9E2A2C-E973-2822-A8C4-C9D743FDCD9A}"/>
-            </a:ext>
-          </a:extLst>
-        </p:cNvPr>
-        <p:cNvGrpSpPr/>
-        <p:nvPr/>
-      </p:nvGrpSpPr>
-      <p:grpSpPr>
-        <a:xfrm>
-          <a:off x="0" y="0"/>
-          <a:ext cx="0" cy="0"/>
-          <a:chOff x="0" y="0"/>
-          <a:chExt cx="0" cy="0"/>
-        </a:xfrm>
-      </p:grpSpPr>
-      <p:sp>
-        <p:nvSpPr>
-          <p:cNvPr id="5" name="CuadroTexto 4">
-            <a:extLst>
-              <a:ext uri="{FF2B5EF4-FFF2-40B4-BE49-F238E27FC236}">
-                <a16:creationId xmlns:a16="http://schemas.microsoft.com/office/drawing/2014/main" id="{169B776E-FE0D-2C7F-AB06-D24F375B3B27}"/>
-              </a:ext>
-            </a:extLst>
-          </p:cNvPr>
-          <p:cNvSpPr txBox="1"/>
-          <p:nvPr/>
-        </p:nvSpPr>
-        <p:spPr>
-          <a:xfrm>
-            <a:off x="1926166" y="88135"/>
-            <a:ext cx="5291667" cy="307777"/>
-          </a:xfrm>
-          <a:prstGeom prst="rect">
-            <a:avLst/>
-          </a:prstGeom>
-          <a:noFill/>
-        </p:spPr>
-        <p:txBody>
-          <a:bodyPr wrap="square" rtlCol="0">
-            <a:spAutoFit/>
-          </a:bodyPr>
-          <a:lstStyle/>
-          <a:p>
-            <a:pPr algn="ctr"/>
-            <a:r>
-              <a:rPr lang="es-MX" b="1" dirty="0">
-                <a:latin typeface="Montserrat" pitchFamily="2" charset="0"/>
-              </a:rPr>
-              <a:t>Opinión emitida por radioescuchas</a:t>
-            </a:r>
-          </a:p>
-        </p:txBody>
-      </p:sp>
-      <p:pic>
-        <p:nvPicPr>
-          <p:cNvPr id="3" name="Imagen 2">
-            <a:extLst>
-              <a:ext uri="{FF2B5EF4-FFF2-40B4-BE49-F238E27FC236}">
-                <a16:creationId xmlns:a16="http://schemas.microsoft.com/office/drawing/2014/main" id="{9F4C952D-4FAA-61A8-A9D4-4DD76F373935}"/>
-              </a:ext>
-            </a:extLst>
-          </p:cNvPr>
-          <p:cNvPicPr>
-            <a:picLocks noChangeAspect="1"/>
-          </p:cNvPicPr>
-          <p:nvPr/>
-        </p:nvPicPr>
-        <p:blipFill>
-          <a:blip r:embed="rId2"/>
-          <a:stretch>
-            <a:fillRect/>
-          </a:stretch>
-        </p:blipFill>
-        <p:spPr>
-          <a:xfrm>
-            <a:off x="542772" y="395912"/>
-            <a:ext cx="7985432" cy="4719881"/>
-          </a:xfrm>
-          <a:prstGeom prst="rect">
-            <a:avLst/>
-          </a:prstGeom>
-        </p:spPr>
-      </p:pic>
-    </p:spTree>
-    <p:extLst>
-      <p:ext uri="{BB962C8B-B14F-4D97-AF65-F5344CB8AC3E}">
-        <p14:creationId xmlns:p14="http://schemas.microsoft.com/office/powerpoint/2010/main" val="1989408123"/>
-      </p:ext>
-    </p:extLst>
-  </p:cSld>
-  <p:clrMapOvr>
-    <a:masterClrMapping/>
-  </p:clrMapOvr>
-</p:sld>
-</file>
-
-<file path=ppt/slides/slide18.xml><?xml version="1.0" encoding="utf-8"?>
 <p:sld xmlns:a="http://schemas.openxmlformats.org/drawingml/2006/main" xmlns:r="http://schemas.openxmlformats.org/officeDocument/2006/relationships" xmlns:p="http://schemas.openxmlformats.org/presentationml/2006/main">
   <p:cSld>
     <p:spTree>
@@ -7600,10 +7487,10 @@
       </p:sp>
       <p:pic>
         <p:nvPicPr>
-          <p:cNvPr id="4" name="Imagen 3">
+          <p:cNvPr id="3" name="Imagen 2">
             <a:extLst>
               <a:ext uri="{FF2B5EF4-FFF2-40B4-BE49-F238E27FC236}">
-                <a16:creationId xmlns:a16="http://schemas.microsoft.com/office/drawing/2014/main" id="{B671A503-B8EB-D762-8DAB-4B4B1FA67796}"/>
+                <a16:creationId xmlns:a16="http://schemas.microsoft.com/office/drawing/2014/main" id="{7B54C8D7-045C-A891-D6C0-FA1CD01AC6DA}"/>
               </a:ext>
             </a:extLst>
           </p:cNvPr>
@@ -7620,8 +7507,8 @@
         </p:blipFill>
         <p:spPr>
           <a:xfrm>
-            <a:off x="0" y="719173"/>
-            <a:ext cx="9144000" cy="3705153"/>
+            <a:off x="0" y="839097"/>
+            <a:ext cx="9144000" cy="3710106"/>
           </a:xfrm>
           <a:prstGeom prst="rect">
             <a:avLst/>
@@ -7712,36 +7599,6 @@
           </a:p>
         </p:txBody>
       </p:sp>
-      <p:pic>
-        <p:nvPicPr>
-          <p:cNvPr id="3" name="Imagen 2">
-            <a:extLst>
-              <a:ext uri="{FF2B5EF4-FFF2-40B4-BE49-F238E27FC236}">
-                <a16:creationId xmlns:a16="http://schemas.microsoft.com/office/drawing/2014/main" id="{7E0908C4-0789-DB46-DD5A-BEFF9C1B72E4}"/>
-              </a:ext>
-            </a:extLst>
-          </p:cNvPr>
-          <p:cNvPicPr>
-            <a:picLocks noChangeAspect="1"/>
-          </p:cNvPicPr>
-          <p:nvPr/>
-        </p:nvPicPr>
-        <p:blipFill>
-          <a:blip r:embed="rId3"/>
-          <a:stretch>
-            <a:fillRect/>
-          </a:stretch>
-        </p:blipFill>
-        <p:spPr>
-          <a:xfrm>
-            <a:off x="0" y="1258111"/>
-            <a:ext cx="9144000" cy="2770153"/>
-          </a:xfrm>
-          <a:prstGeom prst="rect">
-            <a:avLst/>
-          </a:prstGeom>
-        </p:spPr>
-      </p:pic>
     </p:spTree>
     <p:extLst>
       <p:ext uri="{BB962C8B-B14F-4D97-AF65-F5344CB8AC3E}">
@@ -7826,36 +7683,6 @@
           </a:p>
         </p:txBody>
       </p:sp>
-      <p:pic>
-        <p:nvPicPr>
-          <p:cNvPr id="2" name="Imagen 1">
-            <a:extLst>
-              <a:ext uri="{FF2B5EF4-FFF2-40B4-BE49-F238E27FC236}">
-                <a16:creationId xmlns:a16="http://schemas.microsoft.com/office/drawing/2014/main" id="{0BCAB345-F7BC-054A-480C-CB03BDBBB889}"/>
-              </a:ext>
-            </a:extLst>
-          </p:cNvPr>
-          <p:cNvPicPr>
-            <a:picLocks noChangeAspect="1"/>
-          </p:cNvPicPr>
-          <p:nvPr/>
-        </p:nvPicPr>
-        <p:blipFill>
-          <a:blip r:embed="rId3"/>
-          <a:stretch>
-            <a:fillRect/>
-          </a:stretch>
-        </p:blipFill>
-        <p:spPr>
-          <a:xfrm>
-            <a:off x="1113385" y="773100"/>
-            <a:ext cx="6844205" cy="3904200"/>
-          </a:xfrm>
-          <a:prstGeom prst="rect">
-            <a:avLst/>
-          </a:prstGeom>
-        </p:spPr>
-      </p:pic>
     </p:spTree>
     <p:extLst>
       <p:ext uri="{BB962C8B-B14F-4D97-AF65-F5344CB8AC3E}">

</xml_diff>